<commit_message>
release: refresh evidence and video placeholders
</commit_message>
<xml_diff>
--- a/docs/proposal/UchiHahaha_FleetIQGuardian_Final_Round2.pptx
+++ b/docs/proposal/UchiHahaha_FleetIQGuardian_Final_Round2.pptx
@@ -7420,7 +7420,7 @@
                 <a:ea typeface="Quattrocento Sans" pitchFamily="34" charset="-122"/>
                 <a:cs typeface="Quattrocento Sans" pitchFamily="34" charset="-120"/>
               </a:rPr>
-              <a:t>TỪ HÀNG ĐỢI RỦI RO</a:t>
+              <a:t>TỪ RỦI RO ĐẾN</a:t>
             </a:r>
             <a:endParaRPr lang="en-US" sz="3100" dirty="0"/>
           </a:p>
@@ -7437,7 +7437,7 @@
                 <a:ea typeface="Quattrocento Sans" pitchFamily="34" charset="-122"/>
                 <a:cs typeface="Quattrocento Sans" pitchFamily="34" charset="-120"/>
               </a:rPr>
-              <a:t>ĐẾN HƯỚNG DẪN CÓ BẰNG CHỨNG</a:t>
+              <a:t>COACHING CÓ CĂN CỨ</a:t>
             </a:r>
             <a:endParaRPr lang="en-US" sz="3100" dirty="0"/>
           </a:p>
@@ -8135,7 +8135,7 @@
                 <a:ea typeface="Quattrocento Sans" pitchFamily="34" charset="-122"/>
                 <a:cs typeface="Quattrocento Sans" pitchFamily="34" charset="-120"/>
               </a:rPr>
-              <a:t>18.000 FRAME ANALYSIS</a:t>
+              <a:t>10 TRIP ANALYSIS</a:t>
             </a:r>
             <a:endParaRPr lang="en-US" sz="860" dirty="0"/>
           </a:p>
@@ -12874,7 +12874,7 @@
                 <a:ea typeface="Quattrocento Sans" pitchFamily="34" charset="-122"/>
                 <a:cs typeface="Quattrocento Sans" pitchFamily="34" charset="-120"/>
               </a:rPr>
-              <a:t>MỘT ĐỐI TƯỢNG CÓ THỂ KIỂM TRA, KHÔNG PHẢI CẢNH BÁO HỘP ĐEN</a:t>
+              <a:t>MỘT KHUNG HÌNH, BỐN TÍN HIỆU CÓ THỂ KIỂM TRA</a:t>
             </a:r>
             <a:endParaRPr lang="en-US" sz="2700" dirty="0"/>
           </a:p>
@@ -12915,7 +12915,7 @@
                 <a:ea typeface="Quattrocento Sans" pitchFamily="34" charset="-122"/>
                 <a:cs typeface="Quattrocento Sans" pitchFamily="34" charset="-120"/>
               </a:rPr>
-              <a:t>Frame 551 minh họa cách reviewer truy ngược output perception về cảnh gốc.</a:t>
+              <a:t>Khung 1010 được đọc lại từ YOLOP overlay, artifact road/DMS/fusion và CSV sau full pipeline.</a:t>
             </a:r>
             <a:endParaRPr lang="en-US" sz="1080" dirty="0"/>
           </a:p>
@@ -13032,7 +13032,7 @@
         <p:spPr>
           <a:xfrm>
             <a:off x="640080" y="1828800"/>
-            <a:ext cx="5724144" cy="3337560"/>
+            <a:ext cx="6720840" cy="3337560"/>
           </a:xfrm>
           <a:prstGeom prst="rect">
             <a:avLst/>
@@ -13052,7 +13052,7 @@
       </p:sp>
       <p:pic>
         <p:nvPicPr>
-          <p:cNvPr id="10" name="Image 0" descr="C:\Users\admin\Documents\Projects\AutomotiveHacathon\docs\proposal\assets\t01d-motorcycle-evidence.png">    </p:cNvPr>
+          <p:cNvPr id="10" name="Image 0" descr="C:\Users\admin\Documents\Projects\AutomotiveHacathon\docs\proposal\assets\t01d-frame-1010-road-overlay.png">    </p:cNvPr>
           <p:cNvPicPr>
             <a:picLocks noChangeAspect="1"/>
           </p:cNvPicPr>
@@ -13066,8 +13066,8 @@
         </p:blipFill>
         <p:spPr>
           <a:xfrm>
-            <a:off x="804672" y="2029968"/>
-            <a:ext cx="5321808" cy="2990088"/>
+            <a:off x="804672" y="2002536"/>
+            <a:ext cx="6391656" cy="2999232"/>
           </a:xfrm>
           <a:prstGeom prst="rect">
             <a:avLst/>
@@ -13082,8 +13082,8 @@
         </p:nvSpPr>
         <p:spPr>
           <a:xfrm>
-            <a:off x="2103120" y="4572000"/>
-            <a:ext cx="1828800" cy="256032"/>
+            <a:off x="1874520" y="4572000"/>
+            <a:ext cx="4251960" cy="256032"/>
           </a:xfrm>
           <a:prstGeom prst="rect">
             <a:avLst/>
@@ -13109,8 +13109,8 @@
         </p:nvSpPr>
         <p:spPr>
           <a:xfrm>
-            <a:off x="2194560" y="4645152"/>
-            <a:ext cx="1645920" cy="91440"/>
+            <a:off x="1965960" y="4645152"/>
+            <a:ext cx="4069080" cy="91440"/>
           </a:xfrm>
           <a:prstGeom prst="rect">
             <a:avLst/>
@@ -13134,7 +13134,7 @@
                 <a:ea typeface="Quattrocento Sans" pitchFamily="34" charset="-122"/>
                 <a:cs typeface="Quattrocento Sans" pitchFamily="34" charset="-120"/>
               </a:rPr>
-              <a:t>CẢNH GỐC CÓ ANNOTATION</a:t>
+              <a:t>T01D · FRAME 1010 · YOLOP OVERLAY</a:t>
             </a:r>
             <a:endParaRPr lang="en-US" sz="750" dirty="0"/>
           </a:p>
@@ -13148,59 +13148,33 @@
         </p:nvSpPr>
         <p:spPr>
           <a:xfrm>
-            <a:off x="6748272" y="1828800"/>
-            <a:ext cx="2615184" cy="3337560"/>
+            <a:off x="7680960" y="1828800"/>
+            <a:ext cx="3822192" cy="914400"/>
           </a:xfrm>
           <a:prstGeom prst="rect">
             <a:avLst/>
           </a:prstGeom>
           <a:solidFill>
-            <a:srgbClr val="0B1020"/>
+            <a:srgbClr val="FFFFFF"/>
           </a:solidFill>
           <a:ln w="7620">
             <a:solidFill>
-              <a:srgbClr val="0B1020">
-                <a:alpha val="0"/>
-              </a:srgbClr>
-            </a:solidFill>
-            <a:prstDash val="solid"/>
-          </a:ln>
-        </p:spPr>
-      </p:sp>
-      <p:pic>
-        <p:nvPicPr>
-          <p:cNvPr id="14" name="Image 1" descr="C:\Users\admin\Documents\Projects\AutomotiveHacathon\docs\proposal\assets\t01d-motorcycle-crop.png">    </p:cNvPr>
-          <p:cNvPicPr>
-            <a:picLocks noChangeAspect="1"/>
-          </p:cNvPicPr>
-          <p:nvPr/>
-        </p:nvPicPr>
-        <p:blipFill>
-          <a:blip r:embed="rId2"/>
-          <a:stretch>
-            <a:fillRect/>
-          </a:stretch>
-        </p:blipFill>
-        <p:spPr>
-          <a:xfrm>
-            <a:off x="6912864" y="2011680"/>
-            <a:ext cx="2286000" cy="2286000"/>
-          </a:xfrm>
-          <a:prstGeom prst="rect">
-            <a:avLst/>
-          </a:prstGeom>
-        </p:spPr>
-      </p:pic>
-      <p:sp>
-        <p:nvSpPr>
-          <p:cNvPr id="15" name="Shape 11"/>
-          <p:cNvSpPr/>
-          <p:nvPr/>
-        </p:nvSpPr>
-        <p:spPr>
-          <a:xfrm>
-            <a:off x="7150608" y="4498848"/>
-            <a:ext cx="1783080" cy="256032"/>
+              <a:srgbClr val="CDCCCC"/>
+            </a:solidFill>
+            <a:prstDash val="solid"/>
+          </a:ln>
+        </p:spPr>
+      </p:sp>
+      <p:sp>
+        <p:nvSpPr>
+          <p:cNvPr id="14" name="Shape 11"/>
+          <p:cNvSpPr/>
+          <p:nvPr/>
+        </p:nvSpPr>
+        <p:spPr>
+          <a:xfrm>
+            <a:off x="7680960" y="1828800"/>
+            <a:ext cx="73152" cy="914400"/>
           </a:xfrm>
           <a:prstGeom prst="rect">
             <a:avLst/>
@@ -13220,53 +13194,96 @@
       </p:sp>
       <p:sp>
         <p:nvSpPr>
-          <p:cNvPr id="16" name="Text 12"/>
-          <p:cNvSpPr/>
-          <p:nvPr/>
-        </p:nvSpPr>
-        <p:spPr>
-          <a:xfrm>
-            <a:off x="7242048" y="4572000"/>
-            <a:ext cx="1600200" cy="91440"/>
-          </a:xfrm>
-          <a:prstGeom prst="rect">
-            <a:avLst/>
-          </a:prstGeom>
-          <a:noFill/>
-          <a:ln/>
-        </p:spPr>
-        <p:txBody>
-          <a:bodyPr wrap="square" lIns="0" tIns="0" rIns="0" bIns="0" rtlCol="0" anchor="ctr"/>
-          <a:lstStyle/>
-          <a:p>
-            <a:pPr algn="ctr" indent="0" marL="0">
-              <a:buNone/>
-            </a:pPr>
-            <a:r>
-              <a:rPr lang="en-US" sz="750" b="1" spc="60" kern="0" dirty="0">
-                <a:solidFill>
-                  <a:srgbClr val="FFFFFF"/>
-                </a:solidFill>
-                <a:latin typeface="Quattrocento Sans" pitchFamily="34" charset="0"/>
-                <a:ea typeface="Quattrocento Sans" pitchFamily="34" charset="-122"/>
-                <a:cs typeface="Quattrocento Sans" pitchFamily="34" charset="-120"/>
-              </a:rPr>
-              <a:t>CROP PHÓNG TO</a:t>
-            </a:r>
-            <a:endParaRPr lang="en-US" sz="750" dirty="0"/>
-          </a:p>
-        </p:txBody>
-      </p:sp>
-      <p:sp>
-        <p:nvSpPr>
-          <p:cNvPr id="17" name="Shape 13"/>
-          <p:cNvSpPr/>
-          <p:nvPr/>
-        </p:nvSpPr>
-        <p:spPr>
-          <a:xfrm>
-            <a:off x="9646920" y="1828800"/>
-            <a:ext cx="1856232" cy="1417320"/>
+          <p:cNvPr id="15" name="Text 12"/>
+          <p:cNvSpPr/>
+          <p:nvPr/>
+        </p:nvSpPr>
+        <p:spPr>
+          <a:xfrm>
+            <a:off x="7973568" y="2075688"/>
+            <a:ext cx="3200400" cy="164592"/>
+          </a:xfrm>
+          <a:prstGeom prst="rect">
+            <a:avLst/>
+          </a:prstGeom>
+          <a:noFill/>
+          <a:ln/>
+        </p:spPr>
+        <p:txBody>
+          <a:bodyPr wrap="square" lIns="0" tIns="0" rIns="0" bIns="0" rtlCol="0" anchor="ctr">
+            <a:normAutofit/>
+          </a:bodyPr>
+          <a:lstStyle/>
+          <a:p>
+            <a:pPr indent="0" marL="0">
+              <a:buNone/>
+            </a:pPr>
+            <a:r>
+              <a:rPr lang="en-US" sz="1120" b="1" dirty="0">
+                <a:solidFill>
+                  <a:srgbClr val="19226D"/>
+                </a:solidFill>
+                <a:latin typeface="Quattrocento Sans" pitchFamily="34" charset="0"/>
+                <a:ea typeface="Quattrocento Sans" pitchFamily="34" charset="-122"/>
+                <a:cs typeface="Quattrocento Sans" pitchFamily="34" charset="-120"/>
+              </a:rPr>
+              <a:t>ROAD / IN-LANE CAR</a:t>
+            </a:r>
+            <a:endParaRPr lang="en-US" sz="1120" dirty="0"/>
+          </a:p>
+        </p:txBody>
+      </p:sp>
+      <p:sp>
+        <p:nvSpPr>
+          <p:cNvPr id="16" name="Text 13"/>
+          <p:cNvSpPr/>
+          <p:nvPr/>
+        </p:nvSpPr>
+        <p:spPr>
+          <a:xfrm>
+            <a:off x="7973568" y="2359152"/>
+            <a:ext cx="3154680" cy="128016"/>
+          </a:xfrm>
+          <a:prstGeom prst="rect">
+            <a:avLst/>
+          </a:prstGeom>
+          <a:noFill/>
+          <a:ln/>
+        </p:spPr>
+        <p:txBody>
+          <a:bodyPr wrap="square" lIns="0" tIns="0" rIns="0" bIns="0" rtlCol="0" anchor="ctr">
+            <a:normAutofit/>
+          </a:bodyPr>
+          <a:lstStyle/>
+          <a:p>
+            <a:pPr indent="0" marL="0">
+              <a:buNone/>
+            </a:pPr>
+            <a:r>
+              <a:rPr lang="en-US" sz="880" dirty="0">
+                <a:solidFill>
+                  <a:srgbClr val="6B7A90"/>
+                </a:solidFill>
+                <a:latin typeface="Quattrocento Sans" pitchFamily="34" charset="0"/>
+                <a:ea typeface="Quattrocento Sans" pitchFamily="34" charset="-122"/>
+                <a:cs typeface="Quattrocento Sans" pitchFamily="34" charset="-120"/>
+              </a:rPr>
+              <a:t>20.40 m · TTC 1.601 s · confidence 0.8837</a:t>
+            </a:r>
+            <a:endParaRPr lang="en-US" sz="880" dirty="0"/>
+          </a:p>
+        </p:txBody>
+      </p:sp>
+      <p:sp>
+        <p:nvSpPr>
+          <p:cNvPr id="17" name="Shape 14"/>
+          <p:cNvSpPr/>
+          <p:nvPr/>
+        </p:nvSpPr>
+        <p:spPr>
+          <a:xfrm>
+            <a:off x="7680960" y="2907792"/>
+            <a:ext cx="3822192" cy="914400"/>
           </a:xfrm>
           <a:prstGeom prst="rect">
             <a:avLst/>
@@ -13284,24 +13301,24 @@
       </p:sp>
       <p:sp>
         <p:nvSpPr>
-          <p:cNvPr id="18" name="Shape 14"/>
-          <p:cNvSpPr/>
-          <p:nvPr/>
-        </p:nvSpPr>
-        <p:spPr>
-          <a:xfrm>
-            <a:off x="9646920" y="1828800"/>
-            <a:ext cx="73152" cy="1417320"/>
+          <p:cNvPr id="18" name="Shape 15"/>
+          <p:cNvSpPr/>
+          <p:nvPr/>
+        </p:nvSpPr>
+        <p:spPr>
+          <a:xfrm>
+            <a:off x="7680960" y="2907792"/>
+            <a:ext cx="73152" cy="914400"/>
           </a:xfrm>
           <a:prstGeom prst="rect">
             <a:avLst/>
           </a:prstGeom>
           <a:solidFill>
-            <a:srgbClr val="F37021"/>
+            <a:srgbClr val="034EA2"/>
           </a:solidFill>
           <a:ln w="7620">
             <a:solidFill>
-              <a:srgbClr val="F37021">
+              <a:srgbClr val="034EA2">
                 <a:alpha val="0"/>
               </a:srgbClr>
             </a:solidFill>
@@ -13311,14 +13328,14 @@
       </p:sp>
       <p:sp>
         <p:nvSpPr>
-          <p:cNvPr id="19" name="Text 15"/>
-          <p:cNvSpPr/>
-          <p:nvPr/>
-        </p:nvSpPr>
-        <p:spPr>
-          <a:xfrm>
-            <a:off x="9857232" y="2221992"/>
-            <a:ext cx="1389888" cy="347472"/>
+          <p:cNvPr id="19" name="Text 16"/>
+          <p:cNvSpPr/>
+          <p:nvPr/>
+        </p:nvSpPr>
+        <p:spPr>
+          <a:xfrm>
+            <a:off x="7973568" y="3154680"/>
+            <a:ext cx="3200400" cy="164592"/>
           </a:xfrm>
           <a:prstGeom prst="rect">
             <a:avLst/>
@@ -13332,11 +13349,11 @@
           </a:bodyPr>
           <a:lstStyle/>
           <a:p>
-            <a:pPr algn="ctr" indent="0" marL="0">
-              <a:buNone/>
-            </a:pPr>
-            <a:r>
-              <a:rPr lang="en-US" sz="1240" b="1" dirty="0">
+            <a:pPr indent="0" marL="0">
+              <a:buNone/>
+            </a:pPr>
+            <a:r>
+              <a:rPr lang="en-US" sz="1120" b="1" dirty="0">
                 <a:solidFill>
                   <a:srgbClr val="19226D"/>
                 </a:solidFill>
@@ -13344,39 +13361,22 @@
                 <a:ea typeface="Quattrocento Sans" pitchFamily="34" charset="-122"/>
                 <a:cs typeface="Quattrocento Sans" pitchFamily="34" charset="-120"/>
               </a:rPr>
-              <a:t>ĐỐI TƯỢNG</a:t>
-            </a:r>
-            <a:endParaRPr lang="en-US" sz="1240" dirty="0"/>
-          </a:p>
-          <a:p>
-            <a:pPr algn="ctr" indent="0" marL="0">
-              <a:buNone/>
-            </a:pPr>
-            <a:r>
-              <a:rPr lang="en-US" sz="1240" b="1" dirty="0">
-                <a:solidFill>
-                  <a:srgbClr val="19226D"/>
-                </a:solidFill>
-                <a:latin typeface="Quattrocento Sans" pitchFamily="34" charset="0"/>
-                <a:ea typeface="Quattrocento Sans" pitchFamily="34" charset="-122"/>
-                <a:cs typeface="Quattrocento Sans" pitchFamily="34" charset="-120"/>
-              </a:rPr>
-              <a:t>XE MÁY</a:t>
-            </a:r>
-            <a:endParaRPr lang="en-US" sz="1240" dirty="0"/>
-          </a:p>
-        </p:txBody>
-      </p:sp>
-      <p:sp>
-        <p:nvSpPr>
-          <p:cNvPr id="20" name="Text 16"/>
-          <p:cNvSpPr/>
-          <p:nvPr/>
-        </p:nvSpPr>
-        <p:spPr>
-          <a:xfrm>
-            <a:off x="9838944" y="2798064"/>
-            <a:ext cx="1444752" cy="201168"/>
+              <a:t>DMS / DROWSY</a:t>
+            </a:r>
+            <a:endParaRPr lang="en-US" sz="1120" dirty="0"/>
+          </a:p>
+        </p:txBody>
+      </p:sp>
+      <p:sp>
+        <p:nvSpPr>
+          <p:cNvPr id="20" name="Text 17"/>
+          <p:cNvSpPr/>
+          <p:nvPr/>
+        </p:nvSpPr>
+        <p:spPr>
+          <a:xfrm>
+            <a:off x="7973568" y="3438144"/>
+            <a:ext cx="3154680" cy="128016"/>
           </a:xfrm>
           <a:prstGeom prst="rect">
             <a:avLst/>
@@ -13390,34 +13390,34 @@
           </a:bodyPr>
           <a:lstStyle/>
           <a:p>
-            <a:pPr algn="ctr" indent="0" marL="0">
-              <a:buNone/>
-            </a:pPr>
-            <a:r>
-              <a:rPr lang="en-US" sz="740" dirty="0">
-                <a:solidFill>
-                  <a:srgbClr val="34506E"/>
-                </a:solidFill>
-                <a:latin typeface="Quattrocento Sans" pitchFamily="34" charset="0"/>
-                <a:ea typeface="Quattrocento Sans" pitchFamily="34" charset="-122"/>
-                <a:cs typeface="Quattrocento Sans" pitchFamily="34" charset="-120"/>
-              </a:rPr>
-              <a:t>Reviewer kiểm tra trực tiếp bbox và cảnh gốc.</a:t>
-            </a:r>
-            <a:endParaRPr lang="en-US" sz="740" dirty="0"/>
-          </a:p>
-        </p:txBody>
-      </p:sp>
-      <p:sp>
-        <p:nvSpPr>
-          <p:cNvPr id="21" name="Shape 17"/>
-          <p:cNvSpPr/>
-          <p:nvPr/>
-        </p:nvSpPr>
-        <p:spPr>
-          <a:xfrm>
-            <a:off x="9646920" y="3547872"/>
-            <a:ext cx="1856232" cy="1618488"/>
+            <a:pPr indent="0" marL="0">
+              <a:buNone/>
+            </a:pPr>
+            <a:r>
+              <a:rPr lang="en-US" sz="880" dirty="0">
+                <a:solidFill>
+                  <a:srgbClr val="6B7A90"/>
+                </a:solidFill>
+                <a:latin typeface="Quattrocento Sans" pitchFamily="34" charset="0"/>
+                <a:ea typeface="Quattrocento Sans" pitchFamily="34" charset="-122"/>
+                <a:cs typeface="Quattrocento Sans" pitchFamily="34" charset="-120"/>
+              </a:rPr>
+              <a:t>MediaPipe geometry · confidence 0.85</a:t>
+            </a:r>
+            <a:endParaRPr lang="en-US" sz="880" dirty="0"/>
+          </a:p>
+        </p:txBody>
+      </p:sp>
+      <p:sp>
+        <p:nvSpPr>
+          <p:cNvPr id="21" name="Shape 18"/>
+          <p:cNvSpPr/>
+          <p:nvPr/>
+        </p:nvSpPr>
+        <p:spPr>
+          <a:xfrm>
+            <a:off x="7680960" y="3986784"/>
+            <a:ext cx="3822192" cy="1179576"/>
           </a:xfrm>
           <a:prstGeom prst="rect">
             <a:avLst/>
@@ -13435,24 +13435,24 @@
       </p:sp>
       <p:sp>
         <p:nvSpPr>
-          <p:cNvPr id="22" name="Shape 18"/>
-          <p:cNvSpPr/>
-          <p:nvPr/>
-        </p:nvSpPr>
-        <p:spPr>
-          <a:xfrm>
-            <a:off x="9646920" y="3547872"/>
-            <a:ext cx="73152" cy="1618488"/>
+          <p:cNvPr id="22" name="Shape 19"/>
+          <p:cNvSpPr/>
+          <p:nvPr/>
+        </p:nvSpPr>
+        <p:spPr>
+          <a:xfrm>
+            <a:off x="7680960" y="3986784"/>
+            <a:ext cx="73152" cy="1179576"/>
           </a:xfrm>
           <a:prstGeom prst="rect">
             <a:avLst/>
           </a:prstGeom>
           <a:solidFill>
-            <a:srgbClr val="034EA2"/>
+            <a:srgbClr val="22B573"/>
           </a:solidFill>
           <a:ln w="7620">
             <a:solidFill>
-              <a:srgbClr val="034EA2">
+              <a:srgbClr val="22B573">
                 <a:alpha val="0"/>
               </a:srgbClr>
             </a:solidFill>
@@ -13462,14 +13462,14 @@
       </p:sp>
       <p:sp>
         <p:nvSpPr>
-          <p:cNvPr id="23" name="Text 19"/>
-          <p:cNvSpPr/>
-          <p:nvPr/>
-        </p:nvSpPr>
-        <p:spPr>
-          <a:xfrm>
-            <a:off x="9838944" y="3913632"/>
-            <a:ext cx="1444752" cy="164592"/>
+          <p:cNvPr id="23" name="Text 20"/>
+          <p:cNvSpPr/>
+          <p:nvPr/>
+        </p:nvSpPr>
+        <p:spPr>
+          <a:xfrm>
+            <a:off x="7973568" y="4224528"/>
+            <a:ext cx="3200400" cy="164592"/>
           </a:xfrm>
           <a:prstGeom prst="rect">
             <a:avLst/>
@@ -13483,34 +13483,34 @@
           </a:bodyPr>
           <a:lstStyle/>
           <a:p>
-            <a:pPr algn="ctr" indent="0" marL="0">
-              <a:buNone/>
-            </a:pPr>
-            <a:r>
-              <a:rPr lang="en-US" sz="1030" b="1" dirty="0">
-                <a:solidFill>
-                  <a:srgbClr val="034EA2"/>
-                </a:solidFill>
-                <a:latin typeface="Quattrocento Sans" pitchFamily="34" charset="0"/>
-                <a:ea typeface="Quattrocento Sans" pitchFamily="34" charset="-122"/>
-                <a:cs typeface="Quattrocento Sans" pitchFamily="34" charset="-120"/>
-              </a:rPr>
-              <a:t>VÙNG DEPTH ROI</a:t>
-            </a:r>
-            <a:endParaRPr lang="en-US" sz="1030" dirty="0"/>
-          </a:p>
-        </p:txBody>
-      </p:sp>
-      <p:sp>
-        <p:nvSpPr>
-          <p:cNvPr id="24" name="Text 20"/>
-          <p:cNvSpPr/>
-          <p:nvPr/>
-        </p:nvSpPr>
-        <p:spPr>
-          <a:xfrm>
-            <a:off x="9838944" y="4370832"/>
-            <a:ext cx="1444752" cy="256032"/>
+            <a:pPr indent="0" marL="0">
+              <a:buNone/>
+            </a:pPr>
+            <a:r>
+              <a:rPr lang="en-US" sz="1120" b="1" dirty="0">
+                <a:solidFill>
+                  <a:srgbClr val="19226D"/>
+                </a:solidFill>
+                <a:latin typeface="Quattrocento Sans" pitchFamily="34" charset="0"/>
+                <a:ea typeface="Quattrocento Sans" pitchFamily="34" charset="-122"/>
+                <a:cs typeface="Quattrocento Sans" pitchFamily="34" charset="-120"/>
+              </a:rPr>
+              <a:t>FUSION / RISK INDEX 51.0</a:t>
+            </a:r>
+            <a:endParaRPr lang="en-US" sz="1120" dirty="0"/>
+          </a:p>
+        </p:txBody>
+      </p:sp>
+      <p:sp>
+        <p:nvSpPr>
+          <p:cNvPr id="24" name="Text 21"/>
+          <p:cNvSpPr/>
+          <p:nvPr/>
+        </p:nvSpPr>
+        <p:spPr>
+          <a:xfrm>
+            <a:off x="7973568" y="4489704"/>
+            <a:ext cx="3182112" cy="292608"/>
           </a:xfrm>
           <a:prstGeom prst="rect">
             <a:avLst/>
@@ -13524,34 +13524,51 @@
           </a:bodyPr>
           <a:lstStyle/>
           <a:p>
-            <a:pPr algn="ctr" indent="0" marL="0">
-              <a:buNone/>
-            </a:pPr>
-            <a:r>
-              <a:rPr lang="en-US" sz="780" dirty="0">
-                <a:solidFill>
-                  <a:srgbClr val="34506E"/>
-                </a:solidFill>
-                <a:latin typeface="Quattrocento Sans" pitchFamily="34" charset="0"/>
-                <a:ea typeface="Quattrocento Sans" pitchFamily="34" charset="-122"/>
-                <a:cs typeface="Quattrocento Sans" pitchFamily="34" charset="-120"/>
-              </a:rPr>
-              <a:t>Khoảng cách được gắn cùng artifact của khung hình.</a:t>
-            </a:r>
-            <a:endParaRPr lang="en-US" sz="780" dirty="0"/>
-          </a:p>
-        </p:txBody>
-      </p:sp>
-      <p:sp>
-        <p:nvSpPr>
-          <p:cNvPr id="25" name="Text 21"/>
-          <p:cNvSpPr/>
-          <p:nvPr/>
-        </p:nvSpPr>
-        <p:spPr>
-          <a:xfrm>
-            <a:off x="9838944" y="4773168"/>
-            <a:ext cx="1444752" cy="146304"/>
+            <a:pPr indent="0" marL="0">
+              <a:buNone/>
+            </a:pPr>
+            <a:r>
+              <a:rPr lang="en-US" sz="810" dirty="0">
+                <a:solidFill>
+                  <a:srgbClr val="6B7A90"/>
+                </a:solidFill>
+                <a:latin typeface="Quattrocento Sans" pitchFamily="34" charset="0"/>
+                <a:ea typeface="Quattrocento Sans" pitchFamily="34" charset="-122"/>
+                <a:cs typeface="Quattrocento Sans" pitchFamily="34" charset="-120"/>
+              </a:rPr>
+              <a:t>TTC-risk + drowsiness + compound risk</a:t>
+            </a:r>
+            <a:endParaRPr lang="en-US" sz="810" dirty="0"/>
+          </a:p>
+          <a:p>
+            <a:pPr indent="0" marL="0">
+              <a:buNone/>
+            </a:pPr>
+            <a:r>
+              <a:rPr lang="en-US" sz="810" dirty="0">
+                <a:solidFill>
+                  <a:srgbClr val="6B7A90"/>
+                </a:solidFill>
+                <a:latin typeface="Quattrocento Sans" pitchFamily="34" charset="0"/>
+                <a:ea typeface="Quattrocento Sans" pitchFamily="34" charset="-122"/>
+                <a:cs typeface="Quattrocento Sans" pitchFamily="34" charset="-120"/>
+              </a:rPr>
+              <a:t>CSV: 1010, 50.500, 1.601, drowsy, 51.0</a:t>
+            </a:r>
+            <a:endParaRPr lang="en-US" sz="810" dirty="0"/>
+          </a:p>
+        </p:txBody>
+      </p:sp>
+      <p:sp>
+        <p:nvSpPr>
+          <p:cNvPr id="25" name="Text 22"/>
+          <p:cNvSpPr/>
+          <p:nvPr/>
+        </p:nvSpPr>
+        <p:spPr>
+          <a:xfrm>
+            <a:off x="548640" y="6071616"/>
+            <a:ext cx="10789920" cy="182880"/>
           </a:xfrm>
           <a:prstGeom prst="rect">
             <a:avLst/>
@@ -13565,47 +13582,6 @@
           </a:bodyPr>
           <a:lstStyle/>
           <a:p>
-            <a:pPr algn="ctr" indent="0" marL="0">
-              <a:buNone/>
-            </a:pPr>
-            <a:r>
-              <a:rPr lang="en-US" sz="690" b="1" dirty="0">
-                <a:solidFill>
-                  <a:srgbClr val="19226D"/>
-                </a:solidFill>
-                <a:latin typeface="Quattrocento Sans" pitchFamily="34" charset="0"/>
-                <a:ea typeface="Quattrocento Sans" pitchFamily="34" charset="-122"/>
-                <a:cs typeface="Quattrocento Sans" pitchFamily="34" charset="-120"/>
-              </a:rPr>
-              <a:t>Giữ false positive chồng lấp để thấy giới hạn model.</a:t>
-            </a:r>
-            <a:endParaRPr lang="en-US" sz="690" dirty="0"/>
-          </a:p>
-        </p:txBody>
-      </p:sp>
-      <p:sp>
-        <p:nvSpPr>
-          <p:cNvPr id="26" name="Text 22"/>
-          <p:cNvSpPr/>
-          <p:nvPr/>
-        </p:nvSpPr>
-        <p:spPr>
-          <a:xfrm>
-            <a:off x="548640" y="6071616"/>
-            <a:ext cx="10789920" cy="182880"/>
-          </a:xfrm>
-          <a:prstGeom prst="rect">
-            <a:avLst/>
-          </a:prstGeom>
-          <a:noFill/>
-          <a:ln/>
-        </p:spPr>
-        <p:txBody>
-          <a:bodyPr wrap="square" lIns="0" tIns="0" rIns="0" bIns="0" rtlCol="0" anchor="ctr">
-            <a:normAutofit/>
-          </a:bodyPr>
-          <a:lstStyle/>
-          <a:p>
             <a:pPr indent="0" marL="0">
               <a:buNone/>
             </a:pPr>
@@ -13618,7 +13594,7 @@
                 <a:ea typeface="Quattrocento Sans" pitchFamily="34" charset="-122"/>
                 <a:cs typeface="Quattrocento Sans" pitchFamily="34" charset="-120"/>
               </a:rPr>
-              <a:t>artifacts/trips/T01d/analysis/road/000551.json | rendered evidence frame | label comparison.</a:t>
+              <a:t>T01d/1010: road, DMS, fusion JSON; YOLOP overlay; predictions/UchiHahaha/T01d.csv.</a:t>
             </a:r>
             <a:endParaRPr lang="en-US" sz="980" dirty="0"/>
           </a:p>
@@ -15028,7 +15004,7 @@
         <p:spPr>
           <a:xfrm>
             <a:off x="658368" y="1783080"/>
-            <a:ext cx="1883664" cy="658368"/>
+            <a:ext cx="1554480" cy="658368"/>
           </a:xfrm>
           <a:prstGeom prst="rect">
             <a:avLst/>
@@ -15079,8 +15055,8 @@
         </p:nvSpPr>
         <p:spPr>
           <a:xfrm>
-            <a:off x="822960" y="1984248"/>
-            <a:ext cx="1554480" cy="182880"/>
+            <a:off x="786384" y="1984248"/>
+            <a:ext cx="1298448" cy="182880"/>
           </a:xfrm>
           <a:prstGeom prst="rect">
             <a:avLst/>
@@ -15098,7 +15074,7 @@
               <a:buNone/>
             </a:pPr>
             <a:r>
-              <a:rPr lang="en-US" sz="840" b="1" dirty="0">
+              <a:rPr lang="en-US" sz="810" b="1" dirty="0">
                 <a:solidFill>
                   <a:srgbClr val="19226D"/>
                 </a:solidFill>
@@ -15108,14 +15084,14 @@
               </a:rPr>
               <a:t>CAMERA</a:t>
             </a:r>
-            <a:endParaRPr lang="en-US" sz="840" dirty="0"/>
+            <a:endParaRPr lang="en-US" sz="810" dirty="0"/>
           </a:p>
           <a:p>
             <a:pPr algn="ctr" indent="0" marL="0">
               <a:buNone/>
             </a:pPr>
             <a:r>
-              <a:rPr lang="en-US" sz="840" b="1" dirty="0">
+              <a:rPr lang="en-US" sz="810" b="1" dirty="0">
                 <a:solidFill>
                   <a:srgbClr val="19226D"/>
                 </a:solidFill>
@@ -15125,7 +15101,7 @@
               </a:rPr>
               <a:t>ĐƯỜNG</a:t>
             </a:r>
-            <a:endParaRPr lang="en-US" sz="840" dirty="0"/>
+            <a:endParaRPr lang="en-US" sz="810" dirty="0"/>
           </a:p>
         </p:txBody>
       </p:sp>
@@ -15137,7 +15113,7 @@
         </p:nvSpPr>
         <p:spPr>
           <a:xfrm>
-            <a:off x="1600200" y="2487168"/>
+            <a:off x="1435608" y="2487168"/>
             <a:ext cx="0" cy="338328"/>
           </a:xfrm>
           <a:prstGeom prst="line">
@@ -15161,8 +15137,8 @@
         </p:nvSpPr>
         <p:spPr>
           <a:xfrm>
-            <a:off x="2871216" y="1783080"/>
-            <a:ext cx="1883664" cy="658368"/>
+            <a:off x="2286000" y="1783080"/>
+            <a:ext cx="1554480" cy="658368"/>
           </a:xfrm>
           <a:prstGeom prst="rect">
             <a:avLst/>
@@ -15186,7 +15162,124 @@
         </p:nvSpPr>
         <p:spPr>
           <a:xfrm>
-            <a:off x="2871216" y="1783080"/>
+            <a:off x="2286000" y="1783080"/>
+            <a:ext cx="73152" cy="658368"/>
+          </a:xfrm>
+          <a:prstGeom prst="rect">
+            <a:avLst/>
+          </a:prstGeom>
+          <a:solidFill>
+            <a:srgbClr val="034EA2"/>
+          </a:solidFill>
+          <a:ln w="7620">
+            <a:solidFill>
+              <a:srgbClr val="034EA2">
+                <a:alpha val="0"/>
+              </a:srgbClr>
+            </a:solidFill>
+            <a:prstDash val="solid"/>
+          </a:ln>
+        </p:spPr>
+      </p:sp>
+      <p:sp>
+        <p:nvSpPr>
+          <p:cNvPr id="15" name="Text 13"/>
+          <p:cNvSpPr/>
+          <p:nvPr/>
+        </p:nvSpPr>
+        <p:spPr>
+          <a:xfrm>
+            <a:off x="2414016" y="1984248"/>
+            <a:ext cx="1298448" cy="182880"/>
+          </a:xfrm>
+          <a:prstGeom prst="rect">
+            <a:avLst/>
+          </a:prstGeom>
+          <a:noFill/>
+          <a:ln/>
+        </p:spPr>
+        <p:txBody>
+          <a:bodyPr wrap="square" lIns="0" tIns="0" rIns="0" bIns="0" rtlCol="0" anchor="ctr">
+            <a:normAutofit/>
+          </a:bodyPr>
+          <a:lstStyle/>
+          <a:p>
+            <a:pPr algn="ctr" indent="0" marL="0">
+              <a:buNone/>
+            </a:pPr>
+            <a:r>
+              <a:rPr lang="en-US" sz="810" b="1" dirty="0">
+                <a:solidFill>
+                  <a:srgbClr val="19226D"/>
+                </a:solidFill>
+                <a:latin typeface="Quattrocento Sans" pitchFamily="34" charset="0"/>
+                <a:ea typeface="Quattrocento Sans" pitchFamily="34" charset="-122"/>
+                <a:cs typeface="Quattrocento Sans" pitchFamily="34" charset="-120"/>
+              </a:rPr>
+              <a:t>ĐỘ SÂU</a:t>
+            </a:r>
+            <a:endParaRPr lang="en-US" sz="810" dirty="0"/>
+          </a:p>
+        </p:txBody>
+      </p:sp>
+      <p:sp>
+        <p:nvSpPr>
+          <p:cNvPr id="16" name="Shape 14"/>
+          <p:cNvSpPr/>
+          <p:nvPr/>
+        </p:nvSpPr>
+        <p:spPr>
+          <a:xfrm>
+            <a:off x="3063240" y="2487168"/>
+            <a:ext cx="0" cy="338328"/>
+          </a:xfrm>
+          <a:prstGeom prst="line">
+            <a:avLst/>
+          </a:prstGeom>
+          <a:noFill/>
+          <a:ln w="16510">
+            <a:solidFill>
+              <a:srgbClr val="034EA2"/>
+            </a:solidFill>
+            <a:prstDash val="solid"/>
+            <a:tailEnd type="triangle"/>
+          </a:ln>
+        </p:spPr>
+      </p:sp>
+      <p:sp>
+        <p:nvSpPr>
+          <p:cNvPr id="17" name="Shape 15"/>
+          <p:cNvSpPr/>
+          <p:nvPr/>
+        </p:nvSpPr>
+        <p:spPr>
+          <a:xfrm>
+            <a:off x="5148072" y="1783080"/>
+            <a:ext cx="1554480" cy="658368"/>
+          </a:xfrm>
+          <a:prstGeom prst="rect">
+            <a:avLst/>
+          </a:prstGeom>
+          <a:solidFill>
+            <a:srgbClr val="FFFFFF"/>
+          </a:solidFill>
+          <a:ln w="7620">
+            <a:solidFill>
+              <a:srgbClr val="CDCCCC"/>
+            </a:solidFill>
+            <a:prstDash val="solid"/>
+          </a:ln>
+        </p:spPr>
+      </p:sp>
+      <p:sp>
+        <p:nvSpPr>
+          <p:cNvPr id="18" name="Shape 16"/>
+          <p:cNvSpPr/>
+          <p:nvPr/>
+        </p:nvSpPr>
+        <p:spPr>
+          <a:xfrm>
+            <a:off x="5148072" y="1783080"/>
             <a:ext cx="73152" cy="658368"/>
           </a:xfrm>
           <a:prstGeom prst="rect">
@@ -15207,14 +15300,14 @@
       </p:sp>
       <p:sp>
         <p:nvSpPr>
-          <p:cNvPr id="15" name="Text 13"/>
-          <p:cNvSpPr/>
-          <p:nvPr/>
-        </p:nvSpPr>
-        <p:spPr>
-          <a:xfrm>
-            <a:off x="3035808" y="1984248"/>
-            <a:ext cx="1554480" cy="182880"/>
+          <p:cNvPr id="19" name="Text 17"/>
+          <p:cNvSpPr/>
+          <p:nvPr/>
+        </p:nvSpPr>
+        <p:spPr>
+          <a:xfrm>
+            <a:off x="5276088" y="1984248"/>
+            <a:ext cx="1298448" cy="182880"/>
           </a:xfrm>
           <a:prstGeom prst="rect">
             <a:avLst/>
@@ -15232,7 +15325,7 @@
               <a:buNone/>
             </a:pPr>
             <a:r>
-              <a:rPr lang="en-US" sz="840" b="1" dirty="0">
+              <a:rPr lang="en-US" sz="810" b="1" dirty="0">
                 <a:solidFill>
                   <a:srgbClr val="19226D"/>
                 </a:solidFill>
@@ -15242,14 +15335,14 @@
               </a:rPr>
               <a:t>CAMERA</a:t>
             </a:r>
-            <a:endParaRPr lang="en-US" sz="840" dirty="0"/>
+            <a:endParaRPr lang="en-US" sz="810" dirty="0"/>
           </a:p>
           <a:p>
             <a:pPr algn="ctr" indent="0" marL="0">
               <a:buNone/>
             </a:pPr>
             <a:r>
-              <a:rPr lang="en-US" sz="840" b="1" dirty="0">
+              <a:rPr lang="en-US" sz="810" b="1" dirty="0">
                 <a:solidFill>
                   <a:srgbClr val="19226D"/>
                 </a:solidFill>
@@ -15259,19 +15352,19 @@
               </a:rPr>
               <a:t>TÀI XẾ</a:t>
             </a:r>
-            <a:endParaRPr lang="en-US" sz="840" dirty="0"/>
-          </a:p>
-        </p:txBody>
-      </p:sp>
-      <p:sp>
-        <p:nvSpPr>
-          <p:cNvPr id="16" name="Shape 14"/>
-          <p:cNvSpPr/>
-          <p:nvPr/>
-        </p:nvSpPr>
-        <p:spPr>
-          <a:xfrm>
-            <a:off x="3813048" y="2487168"/>
+            <a:endParaRPr lang="en-US" sz="810" dirty="0"/>
+          </a:p>
+        </p:txBody>
+      </p:sp>
+      <p:sp>
+        <p:nvSpPr>
+          <p:cNvPr id="20" name="Shape 18"/>
+          <p:cNvSpPr/>
+          <p:nvPr/>
+        </p:nvSpPr>
+        <p:spPr>
+          <a:xfrm>
+            <a:off x="5925312" y="2487168"/>
             <a:ext cx="0" cy="338328"/>
           </a:xfrm>
           <a:prstGeom prst="line">
@@ -15289,14 +15382,14 @@
       </p:sp>
       <p:sp>
         <p:nvSpPr>
-          <p:cNvPr id="17" name="Shape 15"/>
-          <p:cNvSpPr/>
-          <p:nvPr/>
-        </p:nvSpPr>
-        <p:spPr>
-          <a:xfrm>
-            <a:off x="5084064" y="1783080"/>
-            <a:ext cx="1883664" cy="658368"/>
+          <p:cNvPr id="21" name="Shape 19"/>
+          <p:cNvSpPr/>
+          <p:nvPr/>
+        </p:nvSpPr>
+        <p:spPr>
+          <a:xfrm>
+            <a:off x="8284464" y="1783080"/>
+            <a:ext cx="1554480" cy="658368"/>
           </a:xfrm>
           <a:prstGeom prst="rect">
             <a:avLst/>
@@ -15314,24 +15407,24 @@
       </p:sp>
       <p:sp>
         <p:nvSpPr>
-          <p:cNvPr id="18" name="Shape 16"/>
-          <p:cNvSpPr/>
-          <p:nvPr/>
-        </p:nvSpPr>
-        <p:spPr>
-          <a:xfrm>
-            <a:off x="5084064" y="1783080"/>
+          <p:cNvPr id="22" name="Shape 20"/>
+          <p:cNvSpPr/>
+          <p:nvPr/>
+        </p:nvSpPr>
+        <p:spPr>
+          <a:xfrm>
+            <a:off x="8284464" y="1783080"/>
             <a:ext cx="73152" cy="658368"/>
           </a:xfrm>
           <a:prstGeom prst="rect">
             <a:avLst/>
           </a:prstGeom>
           <a:solidFill>
-            <a:srgbClr val="034EA2"/>
+            <a:srgbClr val="22B573"/>
           </a:solidFill>
           <a:ln w="7620">
             <a:solidFill>
-              <a:srgbClr val="034EA2">
+              <a:srgbClr val="22B573">
                 <a:alpha val="0"/>
               </a:srgbClr>
             </a:solidFill>
@@ -15341,14 +15434,14 @@
       </p:sp>
       <p:sp>
         <p:nvSpPr>
-          <p:cNvPr id="19" name="Text 17"/>
-          <p:cNvSpPr/>
-          <p:nvPr/>
-        </p:nvSpPr>
-        <p:spPr>
-          <a:xfrm>
-            <a:off x="5248656" y="1984248"/>
-            <a:ext cx="1554480" cy="182880"/>
+          <p:cNvPr id="23" name="Text 21"/>
+          <p:cNvSpPr/>
+          <p:nvPr/>
+        </p:nvSpPr>
+        <p:spPr>
+          <a:xfrm>
+            <a:off x="8412480" y="1984248"/>
+            <a:ext cx="1298448" cy="182880"/>
           </a:xfrm>
           <a:prstGeom prst="rect">
             <a:avLst/>
@@ -15366,7 +15459,7 @@
               <a:buNone/>
             </a:pPr>
             <a:r>
-              <a:rPr lang="en-US" sz="840" b="1" dirty="0">
+              <a:rPr lang="en-US" sz="810" b="1" dirty="0">
                 <a:solidFill>
                   <a:srgbClr val="19226D"/>
                 </a:solidFill>
@@ -15374,21 +15467,21 @@
                 <a:ea typeface="Quattrocento Sans" pitchFamily="34" charset="-122"/>
                 <a:cs typeface="Quattrocento Sans" pitchFamily="34" charset="-120"/>
               </a:rPr>
-              <a:t>ĐỘ SÂU</a:t>
-            </a:r>
-            <a:endParaRPr lang="en-US" sz="840" dirty="0"/>
-          </a:p>
-        </p:txBody>
-      </p:sp>
-      <p:sp>
-        <p:nvSpPr>
-          <p:cNvPr id="20" name="Shape 18"/>
-          <p:cNvSpPr/>
-          <p:nvPr/>
-        </p:nvSpPr>
-        <p:spPr>
-          <a:xfrm>
-            <a:off x="6025896" y="2487168"/>
+              <a:t>TELEMETRY</a:t>
+            </a:r>
+            <a:endParaRPr lang="en-US" sz="810" dirty="0"/>
+          </a:p>
+        </p:txBody>
+      </p:sp>
+      <p:sp>
+        <p:nvSpPr>
+          <p:cNvPr id="24" name="Shape 22"/>
+          <p:cNvSpPr/>
+          <p:nvPr/>
+        </p:nvSpPr>
+        <p:spPr>
+          <a:xfrm>
+            <a:off x="9061704" y="2487168"/>
             <a:ext cx="0" cy="338328"/>
           </a:xfrm>
           <a:prstGeom prst="line">
@@ -15397,7 +15490,7 @@
           <a:noFill/>
           <a:ln w="16510">
             <a:solidFill>
-              <a:srgbClr val="034EA2"/>
+              <a:srgbClr val="22B573"/>
             </a:solidFill>
             <a:prstDash val="solid"/>
             <a:tailEnd type="triangle"/>
@@ -15406,14 +15499,14 @@
       </p:sp>
       <p:sp>
         <p:nvSpPr>
-          <p:cNvPr id="21" name="Shape 19"/>
-          <p:cNvSpPr/>
-          <p:nvPr/>
-        </p:nvSpPr>
-        <p:spPr>
-          <a:xfrm>
-            <a:off x="7296912" y="1783080"/>
-            <a:ext cx="1883664" cy="658368"/>
+          <p:cNvPr id="25" name="Shape 23"/>
+          <p:cNvSpPr/>
+          <p:nvPr/>
+        </p:nvSpPr>
+        <p:spPr>
+          <a:xfrm>
+            <a:off x="9930384" y="1783080"/>
+            <a:ext cx="1554480" cy="658368"/>
           </a:xfrm>
           <a:prstGeom prst="rect">
             <a:avLst/>
@@ -15431,130 +15524,13 @@
       </p:sp>
       <p:sp>
         <p:nvSpPr>
-          <p:cNvPr id="22" name="Shape 20"/>
-          <p:cNvSpPr/>
-          <p:nvPr/>
-        </p:nvSpPr>
-        <p:spPr>
-          <a:xfrm>
-            <a:off x="7296912" y="1783080"/>
-            <a:ext cx="73152" cy="658368"/>
-          </a:xfrm>
-          <a:prstGeom prst="rect">
-            <a:avLst/>
-          </a:prstGeom>
-          <a:solidFill>
-            <a:srgbClr val="22B573"/>
-          </a:solidFill>
-          <a:ln w="7620">
-            <a:solidFill>
-              <a:srgbClr val="22B573">
-                <a:alpha val="0"/>
-              </a:srgbClr>
-            </a:solidFill>
-            <a:prstDash val="solid"/>
-          </a:ln>
-        </p:spPr>
-      </p:sp>
-      <p:sp>
-        <p:nvSpPr>
-          <p:cNvPr id="23" name="Text 21"/>
-          <p:cNvSpPr/>
-          <p:nvPr/>
-        </p:nvSpPr>
-        <p:spPr>
-          <a:xfrm>
-            <a:off x="7461504" y="1984248"/>
-            <a:ext cx="1554480" cy="182880"/>
-          </a:xfrm>
-          <a:prstGeom prst="rect">
-            <a:avLst/>
-          </a:prstGeom>
-          <a:noFill/>
-          <a:ln/>
-        </p:spPr>
-        <p:txBody>
-          <a:bodyPr wrap="square" lIns="0" tIns="0" rIns="0" bIns="0" rtlCol="0" anchor="ctr">
-            <a:normAutofit/>
-          </a:bodyPr>
-          <a:lstStyle/>
-          <a:p>
-            <a:pPr algn="ctr" indent="0" marL="0">
-              <a:buNone/>
-            </a:pPr>
-            <a:r>
-              <a:rPr lang="en-US" sz="840" b="1" dirty="0">
-                <a:solidFill>
-                  <a:srgbClr val="19226D"/>
-                </a:solidFill>
-                <a:latin typeface="Quattrocento Sans" pitchFamily="34" charset="0"/>
-                <a:ea typeface="Quattrocento Sans" pitchFamily="34" charset="-122"/>
-                <a:cs typeface="Quattrocento Sans" pitchFamily="34" charset="-120"/>
-              </a:rPr>
-              <a:t>TELEMETRY</a:t>
-            </a:r>
-            <a:endParaRPr lang="en-US" sz="840" dirty="0"/>
-          </a:p>
-        </p:txBody>
-      </p:sp>
-      <p:sp>
-        <p:nvSpPr>
-          <p:cNvPr id="24" name="Shape 22"/>
-          <p:cNvSpPr/>
-          <p:nvPr/>
-        </p:nvSpPr>
-        <p:spPr>
-          <a:xfrm>
-            <a:off x="8238744" y="2487168"/>
-            <a:ext cx="0" cy="338328"/>
-          </a:xfrm>
-          <a:prstGeom prst="line">
-            <a:avLst/>
-          </a:prstGeom>
-          <a:noFill/>
-          <a:ln w="16510">
-            <a:solidFill>
-              <a:srgbClr val="22B573"/>
-            </a:solidFill>
-            <a:prstDash val="solid"/>
-            <a:tailEnd type="triangle"/>
-          </a:ln>
-        </p:spPr>
-      </p:sp>
-      <p:sp>
-        <p:nvSpPr>
-          <p:cNvPr id="25" name="Shape 23"/>
-          <p:cNvSpPr/>
-          <p:nvPr/>
-        </p:nvSpPr>
-        <p:spPr>
-          <a:xfrm>
-            <a:off x="9509760" y="1783080"/>
-            <a:ext cx="1883664" cy="658368"/>
-          </a:xfrm>
-          <a:prstGeom prst="rect">
-            <a:avLst/>
-          </a:prstGeom>
-          <a:solidFill>
-            <a:srgbClr val="FFFFFF"/>
-          </a:solidFill>
-          <a:ln w="7620">
-            <a:solidFill>
-              <a:srgbClr val="CDCCCC"/>
-            </a:solidFill>
-            <a:prstDash val="solid"/>
-          </a:ln>
-        </p:spPr>
-      </p:sp>
-      <p:sp>
-        <p:nvSpPr>
           <p:cNvPr id="26" name="Shape 24"/>
           <p:cNvSpPr/>
           <p:nvPr/>
         </p:nvSpPr>
         <p:spPr>
           <a:xfrm>
-            <a:off x="9509760" y="1783080"/>
+            <a:off x="9930384" y="1783080"/>
             <a:ext cx="73152" cy="658368"/>
           </a:xfrm>
           <a:prstGeom prst="rect">
@@ -15581,8 +15557,8 @@
         </p:nvSpPr>
         <p:spPr>
           <a:xfrm>
-            <a:off x="9674352" y="1984248"/>
-            <a:ext cx="1554480" cy="182880"/>
+            <a:off x="10058400" y="1984248"/>
+            <a:ext cx="1298448" cy="182880"/>
           </a:xfrm>
           <a:prstGeom prst="rect">
             <a:avLst/>
@@ -15600,7 +15576,7 @@
               <a:buNone/>
             </a:pPr>
             <a:r>
-              <a:rPr lang="en-US" sz="840" b="1" dirty="0">
+              <a:rPr lang="en-US" sz="810" b="1" dirty="0">
                 <a:solidFill>
                   <a:srgbClr val="19226D"/>
                 </a:solidFill>
@@ -15610,14 +15586,14 @@
               </a:rPr>
               <a:t>NHÃN +</a:t>
             </a:r>
-            <a:endParaRPr lang="en-US" sz="840" dirty="0"/>
+            <a:endParaRPr lang="en-US" sz="810" dirty="0"/>
           </a:p>
           <a:p>
             <a:pPr algn="ctr" indent="0" marL="0">
               <a:buNone/>
             </a:pPr>
             <a:r>
-              <a:rPr lang="en-US" sz="840" b="1" dirty="0">
+              <a:rPr lang="en-US" sz="810" b="1" dirty="0">
                 <a:solidFill>
                   <a:srgbClr val="19226D"/>
                 </a:solidFill>
@@ -15627,7 +15603,7 @@
               </a:rPr>
               <a:t>FUSION</a:t>
             </a:r>
-            <a:endParaRPr lang="en-US" sz="840" dirty="0"/>
+            <a:endParaRPr lang="en-US" sz="810" dirty="0"/>
           </a:p>
         </p:txBody>
       </p:sp>
@@ -15639,7 +15615,7 @@
         </p:nvSpPr>
         <p:spPr>
           <a:xfrm>
-            <a:off x="10451592" y="2487168"/>
+            <a:off x="10707624" y="2487168"/>
             <a:ext cx="0" cy="338328"/>
           </a:xfrm>
           <a:prstGeom prst="line">

</xml_diff>